<commit_message>
incrementa o arquivo de apresentação com novo diagrama do banco de dados com tipos de dados
</commit_message>
<xml_diff>
--- a/projeto-move-plus/apresentacao-move-plus.pptx
+++ b/projeto-move-plus/apresentacao-move-plus.pptx
@@ -32251,17 +32251,16 @@
       </p:sp>
       <p:pic>
         <p:nvPicPr>
-          <p:cNvPr id="250" name="Google Shape;250;p29" title="Move+.drawio.png"/>
+          <p:cNvPr id="250" name="Google Shape;250;p29" title="Move+.drawio (1).png"/>
           <p:cNvPicPr preferRelativeResize="0"/>
           <p:nvPr/>
         </p:nvPicPr>
-        <p:blipFill>
+        <p:blipFill rotWithShape="1">
           <a:blip r:embed="rId5">
             <a:alphaModFix/>
           </a:blip>
-          <a:stretch>
-            <a:fillRect/>
-          </a:stretch>
+          <a:srcRect b="0" l="0" r="0" t="0"/>
+          <a:stretch/>
         </p:blipFill>
         <p:spPr>
           <a:xfrm>

</xml_diff>